<commit_message>
Update GDR and 4-SAT intro slide decks.
Co-authored-by: Cursor <cursoragent@cursor.com>
</commit_message>
<xml_diff>
--- a/ppt/four_sat_intro.pptx
+++ b/ppt/four_sat_intro.pptx
@@ -1,16 +1,16 @@
 
 <file path=ppt/presentation.xml><?xml version="1.0" encoding="utf-8"?>
-<p:presentation xmlns:a="http://schemas.openxmlformats.org/drawingml/2006/main" xmlns:r="http://schemas.openxmlformats.org/officeDocument/2006/relationships" xmlns:p="http://schemas.openxmlformats.org/presentationml/2006/main" saveSubsetFonts="1" autoCompressPictures="0">
+<p:presentation xmlns:a="http://schemas.openxmlformats.org/drawingml/2006/main" xmlns:r="http://schemas.openxmlformats.org/officeDocument/2006/relationships" xmlns:p="http://schemas.openxmlformats.org/presentationml/2006/main" autoCompressPictures="0">
   <p:sldMasterIdLst>
     <p:sldMasterId id="2147483648" r:id="rId1"/>
   </p:sldMasterIdLst>
   <p:sldIdLst>
-    <p:sldId id="256" r:id="rId7"/>
-    <p:sldId id="257" r:id="rId8"/>
-    <p:sldId id="258" r:id="rId9"/>
-    <p:sldId id="259" r:id="rId10"/>
+    <p:sldId id="256" r:id="rId3"/>
+    <p:sldId id="257" r:id="rId4"/>
+    <p:sldId id="258" r:id="rId5"/>
+    <p:sldId id="259" r:id="rId6"/>
   </p:sldIdLst>
-  <p:sldSz cx="12191695" cy="6858000" type="screen4x3"/>
+  <p:sldSz cx="12191365" cy="6858000" type="screen4x3"/>
   <p:notesSz cx="6858000" cy="9144000"/>
   <p:defaultTextStyle>
     <a:defPPr>
@@ -107,6 +107,22 @@
       </a:defRPr>
     </a:lvl9pPr>
   </p:defaultTextStyle>
+  <p:extLst>
+    <p:ext uri="{EFAFB233-063F-42B5-8137-9DF3F51BA10A}">
+      <p15:sldGuideLst xmlns:p15="http://schemas.microsoft.com/office/powerpoint/2012/main">
+        <p15:guide id="1" orient="horz" pos="2160" userDrawn="1">
+          <p15:clr>
+            <a:srgbClr val="A4A3A4"/>
+          </p15:clr>
+        </p15:guide>
+        <p15:guide id="2" pos="2880" userDrawn="1">
+          <p15:clr>
+            <a:srgbClr val="A4A3A4"/>
+          </p15:clr>
+        </p15:guide>
+      </p15:sldGuideLst>
+    </p:ext>
+  </p:extLst>
 </p:presentation>
 </file>
 
@@ -291,7 +307,6 @@
           <a:p>
             <a:fld id="{5BCAD085-E8A6-8845-BD4E-CB4CCA059FC4}" type="datetimeFigureOut">
               <a:rPr lang="en-US" smtClean="0"/>
-              <a:t>1/27/13</a:t>
             </a:fld>
             <a:endParaRPr lang="en-US"/>
           </a:p>
@@ -333,18 +348,12 @@
           <a:p>
             <a:fld id="{C1FF6DA9-008F-8B48-92A6-B652298478BF}" type="slidenum">
               <a:rPr lang="en-US" smtClean="0"/>
-              <a:t>‹#›</a:t>
             </a:fld>
             <a:endParaRPr lang="en-US"/>
           </a:p>
         </p:txBody>
       </p:sp>
     </p:spTree>
-    <p:extLst>
-      <p:ext uri="{BB962C8B-B14F-4D97-AF65-F5344CB8AC3E}">
-        <p14:creationId xmlns:p14="http://schemas.microsoft.com/office/powerpoint/2010/main" val="3168075583"/>
-      </p:ext>
-    </p:extLst>
   </p:cSld>
   <p:clrMapOvr>
     <a:masterClrMapping/>
@@ -412,6 +421,7 @@
               <a:rPr lang="en-US" smtClean="0"/>
               <a:t>Click to edit Master text styles</a:t>
             </a:r>
+            <a:endParaRPr lang="en-US" smtClean="0"/>
           </a:p>
           <a:p>
             <a:pPr lvl="1"/>
@@ -419,6 +429,7 @@
               <a:rPr lang="en-US" smtClean="0"/>
               <a:t>Second level</a:t>
             </a:r>
+            <a:endParaRPr lang="en-US" smtClean="0"/>
           </a:p>
           <a:p>
             <a:pPr lvl="2"/>
@@ -426,6 +437,7 @@
               <a:rPr lang="en-US" smtClean="0"/>
               <a:t>Third level</a:t>
             </a:r>
+            <a:endParaRPr lang="en-US" smtClean="0"/>
           </a:p>
           <a:p>
             <a:pPr lvl="3"/>
@@ -433,6 +445,7 @@
               <a:rPr lang="en-US" smtClean="0"/>
               <a:t>Fourth level</a:t>
             </a:r>
+            <a:endParaRPr lang="en-US" smtClean="0"/>
           </a:p>
           <a:p>
             <a:pPr lvl="4"/>
@@ -461,7 +474,6 @@
           <a:p>
             <a:fld id="{5BCAD085-E8A6-8845-BD4E-CB4CCA059FC4}" type="datetimeFigureOut">
               <a:rPr lang="en-US" smtClean="0"/>
-              <a:t>1/27/13</a:t>
             </a:fld>
             <a:endParaRPr lang="en-US"/>
           </a:p>
@@ -503,18 +515,12 @@
           <a:p>
             <a:fld id="{C1FF6DA9-008F-8B48-92A6-B652298478BF}" type="slidenum">
               <a:rPr lang="en-US" smtClean="0"/>
-              <a:t>‹#›</a:t>
             </a:fld>
             <a:endParaRPr lang="en-US"/>
           </a:p>
         </p:txBody>
       </p:sp>
     </p:spTree>
-    <p:extLst>
-      <p:ext uri="{BB962C8B-B14F-4D97-AF65-F5344CB8AC3E}">
-        <p14:creationId xmlns:p14="http://schemas.microsoft.com/office/powerpoint/2010/main" val="2910927964"/>
-      </p:ext>
-    </p:extLst>
   </p:cSld>
   <p:clrMapOvr>
     <a:masterClrMapping/>
@@ -592,6 +598,7 @@
               <a:rPr lang="en-US" smtClean="0"/>
               <a:t>Click to edit Master text styles</a:t>
             </a:r>
+            <a:endParaRPr lang="en-US" smtClean="0"/>
           </a:p>
           <a:p>
             <a:pPr lvl="1"/>
@@ -599,6 +606,7 @@
               <a:rPr lang="en-US" smtClean="0"/>
               <a:t>Second level</a:t>
             </a:r>
+            <a:endParaRPr lang="en-US" smtClean="0"/>
           </a:p>
           <a:p>
             <a:pPr lvl="2"/>
@@ -606,6 +614,7 @@
               <a:rPr lang="en-US" smtClean="0"/>
               <a:t>Third level</a:t>
             </a:r>
+            <a:endParaRPr lang="en-US" smtClean="0"/>
           </a:p>
           <a:p>
             <a:pPr lvl="3"/>
@@ -613,6 +622,7 @@
               <a:rPr lang="en-US" smtClean="0"/>
               <a:t>Fourth level</a:t>
             </a:r>
+            <a:endParaRPr lang="en-US" smtClean="0"/>
           </a:p>
           <a:p>
             <a:pPr lvl="4"/>
@@ -641,7 +651,6 @@
           <a:p>
             <a:fld id="{5BCAD085-E8A6-8845-BD4E-CB4CCA059FC4}" type="datetimeFigureOut">
               <a:rPr lang="en-US" smtClean="0"/>
-              <a:t>1/27/13</a:t>
             </a:fld>
             <a:endParaRPr lang="en-US"/>
           </a:p>
@@ -683,18 +692,12 @@
           <a:p>
             <a:fld id="{C1FF6DA9-008F-8B48-92A6-B652298478BF}" type="slidenum">
               <a:rPr lang="en-US" smtClean="0"/>
-              <a:t>‹#›</a:t>
             </a:fld>
             <a:endParaRPr lang="en-US"/>
           </a:p>
         </p:txBody>
       </p:sp>
     </p:spTree>
-    <p:extLst>
-      <p:ext uri="{BB962C8B-B14F-4D97-AF65-F5344CB8AC3E}">
-        <p14:creationId xmlns:p14="http://schemas.microsoft.com/office/powerpoint/2010/main" val="3612223792"/>
-      </p:ext>
-    </p:extLst>
   </p:cSld>
   <p:clrMapOvr>
     <a:masterClrMapping/>
@@ -762,6 +765,7 @@
               <a:rPr lang="en-US" smtClean="0"/>
               <a:t>Click to edit Master text styles</a:t>
             </a:r>
+            <a:endParaRPr lang="en-US" smtClean="0"/>
           </a:p>
           <a:p>
             <a:pPr lvl="1"/>
@@ -769,6 +773,7 @@
               <a:rPr lang="en-US" smtClean="0"/>
               <a:t>Second level</a:t>
             </a:r>
+            <a:endParaRPr lang="en-US" smtClean="0"/>
           </a:p>
           <a:p>
             <a:pPr lvl="2"/>
@@ -776,6 +781,7 @@
               <a:rPr lang="en-US" smtClean="0"/>
               <a:t>Third level</a:t>
             </a:r>
+            <a:endParaRPr lang="en-US" smtClean="0"/>
           </a:p>
           <a:p>
             <a:pPr lvl="3"/>
@@ -783,6 +789,7 @@
               <a:rPr lang="en-US" smtClean="0"/>
               <a:t>Fourth level</a:t>
             </a:r>
+            <a:endParaRPr lang="en-US" smtClean="0"/>
           </a:p>
           <a:p>
             <a:pPr lvl="4"/>
@@ -811,7 +818,6 @@
           <a:p>
             <a:fld id="{5BCAD085-E8A6-8845-BD4E-CB4CCA059FC4}" type="datetimeFigureOut">
               <a:rPr lang="en-US" smtClean="0"/>
-              <a:t>1/27/13</a:t>
             </a:fld>
             <a:endParaRPr lang="en-US"/>
           </a:p>
@@ -853,18 +859,12 @@
           <a:p>
             <a:fld id="{C1FF6DA9-008F-8B48-92A6-B652298478BF}" type="slidenum">
               <a:rPr lang="en-US" smtClean="0"/>
-              <a:t>‹#›</a:t>
             </a:fld>
             <a:endParaRPr lang="en-US"/>
           </a:p>
         </p:txBody>
       </p:sp>
     </p:spTree>
-    <p:extLst>
-      <p:ext uri="{BB962C8B-B14F-4D97-AF65-F5344CB8AC3E}">
-        <p14:creationId xmlns:p14="http://schemas.microsoft.com/office/powerpoint/2010/main" val="2614314258"/>
-      </p:ext>
-    </p:extLst>
   </p:cSld>
   <p:clrMapOvr>
     <a:masterClrMapping/>
@@ -1037,6 +1037,7 @@
               <a:rPr lang="en-US" smtClean="0"/>
               <a:t>Click to edit Master text styles</a:t>
             </a:r>
+            <a:endParaRPr lang="en-US" smtClean="0"/>
           </a:p>
         </p:txBody>
       </p:sp>
@@ -1057,7 +1058,6 @@
           <a:p>
             <a:fld id="{5BCAD085-E8A6-8845-BD4E-CB4CCA059FC4}" type="datetimeFigureOut">
               <a:rPr lang="en-US" smtClean="0"/>
-              <a:t>1/27/13</a:t>
             </a:fld>
             <a:endParaRPr lang="en-US"/>
           </a:p>
@@ -1099,18 +1099,12 @@
           <a:p>
             <a:fld id="{C1FF6DA9-008F-8B48-92A6-B652298478BF}" type="slidenum">
               <a:rPr lang="en-US" smtClean="0"/>
-              <a:t>‹#›</a:t>
             </a:fld>
             <a:endParaRPr lang="en-US"/>
           </a:p>
         </p:txBody>
       </p:sp>
     </p:spTree>
-    <p:extLst>
-      <p:ext uri="{BB962C8B-B14F-4D97-AF65-F5344CB8AC3E}">
-        <p14:creationId xmlns:p14="http://schemas.microsoft.com/office/powerpoint/2010/main" val="960648375"/>
-      </p:ext>
-    </p:extLst>
   </p:cSld>
   <p:clrMapOvr>
     <a:masterClrMapping/>
@@ -1211,6 +1205,7 @@
               <a:rPr lang="en-US" smtClean="0"/>
               <a:t>Click to edit Master text styles</a:t>
             </a:r>
+            <a:endParaRPr lang="en-US" smtClean="0"/>
           </a:p>
           <a:p>
             <a:pPr lvl="1"/>
@@ -1218,6 +1213,7 @@
               <a:rPr lang="en-US" smtClean="0"/>
               <a:t>Second level</a:t>
             </a:r>
+            <a:endParaRPr lang="en-US" smtClean="0"/>
           </a:p>
           <a:p>
             <a:pPr lvl="2"/>
@@ -1225,6 +1221,7 @@
               <a:rPr lang="en-US" smtClean="0"/>
               <a:t>Third level</a:t>
             </a:r>
+            <a:endParaRPr lang="en-US" smtClean="0"/>
           </a:p>
           <a:p>
             <a:pPr lvl="3"/>
@@ -1232,6 +1229,7 @@
               <a:rPr lang="en-US" smtClean="0"/>
               <a:t>Fourth level</a:t>
             </a:r>
+            <a:endParaRPr lang="en-US" smtClean="0"/>
           </a:p>
           <a:p>
             <a:pPr lvl="4"/>
@@ -1296,6 +1294,7 @@
               <a:rPr lang="en-US" smtClean="0"/>
               <a:t>Click to edit Master text styles</a:t>
             </a:r>
+            <a:endParaRPr lang="en-US" smtClean="0"/>
           </a:p>
           <a:p>
             <a:pPr lvl="1"/>
@@ -1303,6 +1302,7 @@
               <a:rPr lang="en-US" smtClean="0"/>
               <a:t>Second level</a:t>
             </a:r>
+            <a:endParaRPr lang="en-US" smtClean="0"/>
           </a:p>
           <a:p>
             <a:pPr lvl="2"/>
@@ -1310,6 +1310,7 @@
               <a:rPr lang="en-US" smtClean="0"/>
               <a:t>Third level</a:t>
             </a:r>
+            <a:endParaRPr lang="en-US" smtClean="0"/>
           </a:p>
           <a:p>
             <a:pPr lvl="3"/>
@@ -1317,6 +1318,7 @@
               <a:rPr lang="en-US" smtClean="0"/>
               <a:t>Fourth level</a:t>
             </a:r>
+            <a:endParaRPr lang="en-US" smtClean="0"/>
           </a:p>
           <a:p>
             <a:pPr lvl="4"/>
@@ -1345,7 +1347,6 @@
           <a:p>
             <a:fld id="{5BCAD085-E8A6-8845-BD4E-CB4CCA059FC4}" type="datetimeFigureOut">
               <a:rPr lang="en-US" smtClean="0"/>
-              <a:t>1/27/13</a:t>
             </a:fld>
             <a:endParaRPr lang="en-US"/>
           </a:p>
@@ -1387,18 +1388,12 @@
           <a:p>
             <a:fld id="{C1FF6DA9-008F-8B48-92A6-B652298478BF}" type="slidenum">
               <a:rPr lang="en-US" smtClean="0"/>
-              <a:t>‹#›</a:t>
             </a:fld>
             <a:endParaRPr lang="en-US"/>
           </a:p>
         </p:txBody>
       </p:sp>
     </p:spTree>
-    <p:extLst>
-      <p:ext uri="{BB962C8B-B14F-4D97-AF65-F5344CB8AC3E}">
-        <p14:creationId xmlns:p14="http://schemas.microsoft.com/office/powerpoint/2010/main" val="2782244947"/>
-      </p:ext>
-    </p:extLst>
   </p:cSld>
   <p:clrMapOvr>
     <a:masterClrMapping/>
@@ -1512,6 +1507,7 @@
               <a:rPr lang="en-US" smtClean="0"/>
               <a:t>Click to edit Master text styles</a:t>
             </a:r>
+            <a:endParaRPr lang="en-US" smtClean="0"/>
           </a:p>
         </p:txBody>
       </p:sp>
@@ -1568,6 +1564,7 @@
               <a:rPr lang="en-US" smtClean="0"/>
               <a:t>Click to edit Master text styles</a:t>
             </a:r>
+            <a:endParaRPr lang="en-US" smtClean="0"/>
           </a:p>
           <a:p>
             <a:pPr lvl="1"/>
@@ -1575,6 +1572,7 @@
               <a:rPr lang="en-US" smtClean="0"/>
               <a:t>Second level</a:t>
             </a:r>
+            <a:endParaRPr lang="en-US" smtClean="0"/>
           </a:p>
           <a:p>
             <a:pPr lvl="2"/>
@@ -1582,6 +1580,7 @@
               <a:rPr lang="en-US" smtClean="0"/>
               <a:t>Third level</a:t>
             </a:r>
+            <a:endParaRPr lang="en-US" smtClean="0"/>
           </a:p>
           <a:p>
             <a:pPr lvl="3"/>
@@ -1589,6 +1588,7 @@
               <a:rPr lang="en-US" smtClean="0"/>
               <a:t>Fourth level</a:t>
             </a:r>
+            <a:endParaRPr lang="en-US" smtClean="0"/>
           </a:p>
           <a:p>
             <a:pPr lvl="4"/>
@@ -1662,6 +1662,7 @@
               <a:rPr lang="en-US" smtClean="0"/>
               <a:t>Click to edit Master text styles</a:t>
             </a:r>
+            <a:endParaRPr lang="en-US" smtClean="0"/>
           </a:p>
         </p:txBody>
       </p:sp>
@@ -1718,6 +1719,7 @@
               <a:rPr lang="en-US" smtClean="0"/>
               <a:t>Click to edit Master text styles</a:t>
             </a:r>
+            <a:endParaRPr lang="en-US" smtClean="0"/>
           </a:p>
           <a:p>
             <a:pPr lvl="1"/>
@@ -1725,6 +1727,7 @@
               <a:rPr lang="en-US" smtClean="0"/>
               <a:t>Second level</a:t>
             </a:r>
+            <a:endParaRPr lang="en-US" smtClean="0"/>
           </a:p>
           <a:p>
             <a:pPr lvl="2"/>
@@ -1732,6 +1735,7 @@
               <a:rPr lang="en-US" smtClean="0"/>
               <a:t>Third level</a:t>
             </a:r>
+            <a:endParaRPr lang="en-US" smtClean="0"/>
           </a:p>
           <a:p>
             <a:pPr lvl="3"/>
@@ -1739,6 +1743,7 @@
               <a:rPr lang="en-US" smtClean="0"/>
               <a:t>Fourth level</a:t>
             </a:r>
+            <a:endParaRPr lang="en-US" smtClean="0"/>
           </a:p>
           <a:p>
             <a:pPr lvl="4"/>
@@ -1767,7 +1772,6 @@
           <a:p>
             <a:fld id="{5BCAD085-E8A6-8845-BD4E-CB4CCA059FC4}" type="datetimeFigureOut">
               <a:rPr lang="en-US" smtClean="0"/>
-              <a:t>1/27/13</a:t>
             </a:fld>
             <a:endParaRPr lang="en-US"/>
           </a:p>
@@ -1809,18 +1813,12 @@
           <a:p>
             <a:fld id="{C1FF6DA9-008F-8B48-92A6-B652298478BF}" type="slidenum">
               <a:rPr lang="en-US" smtClean="0"/>
-              <a:t>‹#›</a:t>
             </a:fld>
             <a:endParaRPr lang="en-US"/>
           </a:p>
         </p:txBody>
       </p:sp>
     </p:spTree>
-    <p:extLst>
-      <p:ext uri="{BB962C8B-B14F-4D97-AF65-F5344CB8AC3E}">
-        <p14:creationId xmlns:p14="http://schemas.microsoft.com/office/powerpoint/2010/main" val="990158736"/>
-      </p:ext>
-    </p:extLst>
   </p:cSld>
   <p:clrMapOvr>
     <a:masterClrMapping/>
@@ -1885,7 +1883,6 @@
           <a:p>
             <a:fld id="{5BCAD085-E8A6-8845-BD4E-CB4CCA059FC4}" type="datetimeFigureOut">
               <a:rPr lang="en-US" smtClean="0"/>
-              <a:t>1/27/13</a:t>
             </a:fld>
             <a:endParaRPr lang="en-US"/>
           </a:p>
@@ -1927,18 +1924,12 @@
           <a:p>
             <a:fld id="{C1FF6DA9-008F-8B48-92A6-B652298478BF}" type="slidenum">
               <a:rPr lang="en-US" smtClean="0"/>
-              <a:t>‹#›</a:t>
             </a:fld>
             <a:endParaRPr lang="en-US"/>
           </a:p>
         </p:txBody>
       </p:sp>
     </p:spTree>
-    <p:extLst>
-      <p:ext uri="{BB962C8B-B14F-4D97-AF65-F5344CB8AC3E}">
-        <p14:creationId xmlns:p14="http://schemas.microsoft.com/office/powerpoint/2010/main" val="727027711"/>
-      </p:ext>
-    </p:extLst>
   </p:cSld>
   <p:clrMapOvr>
     <a:masterClrMapping/>
@@ -1980,7 +1971,6 @@
           <a:p>
             <a:fld id="{5BCAD085-E8A6-8845-BD4E-CB4CCA059FC4}" type="datetimeFigureOut">
               <a:rPr lang="en-US" smtClean="0"/>
-              <a:t>1/27/13</a:t>
             </a:fld>
             <a:endParaRPr lang="en-US"/>
           </a:p>
@@ -2022,18 +2012,12 @@
           <a:p>
             <a:fld id="{C1FF6DA9-008F-8B48-92A6-B652298478BF}" type="slidenum">
               <a:rPr lang="en-US" smtClean="0"/>
-              <a:t>‹#›</a:t>
             </a:fld>
             <a:endParaRPr lang="en-US"/>
           </a:p>
         </p:txBody>
       </p:sp>
     </p:spTree>
-    <p:extLst>
-      <p:ext uri="{BB962C8B-B14F-4D97-AF65-F5344CB8AC3E}">
-        <p14:creationId xmlns:p14="http://schemas.microsoft.com/office/powerpoint/2010/main" val="1212999818"/>
-      </p:ext>
-    </p:extLst>
   </p:cSld>
   <p:clrMapOvr>
     <a:masterClrMapping/>
@@ -2143,6 +2127,7 @@
               <a:rPr lang="en-US" smtClean="0"/>
               <a:t>Click to edit Master text styles</a:t>
             </a:r>
+            <a:endParaRPr lang="en-US" smtClean="0"/>
           </a:p>
           <a:p>
             <a:pPr lvl="1"/>
@@ -2150,6 +2135,7 @@
               <a:rPr lang="en-US" smtClean="0"/>
               <a:t>Second level</a:t>
             </a:r>
+            <a:endParaRPr lang="en-US" smtClean="0"/>
           </a:p>
           <a:p>
             <a:pPr lvl="2"/>
@@ -2157,6 +2143,7 @@
               <a:rPr lang="en-US" smtClean="0"/>
               <a:t>Third level</a:t>
             </a:r>
+            <a:endParaRPr lang="en-US" smtClean="0"/>
           </a:p>
           <a:p>
             <a:pPr lvl="3"/>
@@ -2164,6 +2151,7 @@
               <a:rPr lang="en-US" smtClean="0"/>
               <a:t>Fourth level</a:t>
             </a:r>
+            <a:endParaRPr lang="en-US" smtClean="0"/>
           </a:p>
           <a:p>
             <a:pPr lvl="4"/>
@@ -2237,6 +2225,7 @@
               <a:rPr lang="en-US" smtClean="0"/>
               <a:t>Click to edit Master text styles</a:t>
             </a:r>
+            <a:endParaRPr lang="en-US" smtClean="0"/>
           </a:p>
         </p:txBody>
       </p:sp>
@@ -2257,7 +2246,6 @@
           <a:p>
             <a:fld id="{5BCAD085-E8A6-8845-BD4E-CB4CCA059FC4}" type="datetimeFigureOut">
               <a:rPr lang="en-US" smtClean="0"/>
-              <a:t>1/27/13</a:t>
             </a:fld>
             <a:endParaRPr lang="en-US"/>
           </a:p>
@@ -2299,18 +2287,12 @@
           <a:p>
             <a:fld id="{C1FF6DA9-008F-8B48-92A6-B652298478BF}" type="slidenum">
               <a:rPr lang="en-US" smtClean="0"/>
-              <a:t>‹#›</a:t>
             </a:fld>
             <a:endParaRPr lang="en-US"/>
           </a:p>
         </p:txBody>
       </p:sp>
     </p:spTree>
-    <p:extLst>
-      <p:ext uri="{BB962C8B-B14F-4D97-AF65-F5344CB8AC3E}">
-        <p14:creationId xmlns:p14="http://schemas.microsoft.com/office/powerpoint/2010/main" val="1840726560"/>
-      </p:ext>
-    </p:extLst>
   </p:cSld>
   <p:clrMapOvr>
     <a:masterClrMapping/>
@@ -2490,6 +2472,7 @@
               <a:rPr lang="en-US" smtClean="0"/>
               <a:t>Click to edit Master text styles</a:t>
             </a:r>
+            <a:endParaRPr lang="en-US" smtClean="0"/>
           </a:p>
         </p:txBody>
       </p:sp>
@@ -2510,7 +2493,6 @@
           <a:p>
             <a:fld id="{5BCAD085-E8A6-8845-BD4E-CB4CCA059FC4}" type="datetimeFigureOut">
               <a:rPr lang="en-US" smtClean="0"/>
-              <a:t>1/27/13</a:t>
             </a:fld>
             <a:endParaRPr lang="en-US"/>
           </a:p>
@@ -2552,18 +2534,12 @@
           <a:p>
             <a:fld id="{C1FF6DA9-008F-8B48-92A6-B652298478BF}" type="slidenum">
               <a:rPr lang="en-US" smtClean="0"/>
-              <a:t>‹#›</a:t>
             </a:fld>
             <a:endParaRPr lang="en-US"/>
           </a:p>
         </p:txBody>
       </p:sp>
     </p:spTree>
-    <p:extLst>
-      <p:ext uri="{BB962C8B-B14F-4D97-AF65-F5344CB8AC3E}">
-        <p14:creationId xmlns:p14="http://schemas.microsoft.com/office/powerpoint/2010/main" val="3889236939"/>
-      </p:ext>
-    </p:extLst>
   </p:cSld>
   <p:clrMapOvr>
     <a:masterClrMapping/>
@@ -2656,6 +2632,7 @@
               <a:rPr lang="en-US" smtClean="0"/>
               <a:t>Click to edit Master text styles</a:t>
             </a:r>
+            <a:endParaRPr lang="en-US" smtClean="0"/>
           </a:p>
           <a:p>
             <a:pPr lvl="1"/>
@@ -2663,6 +2640,7 @@
               <a:rPr lang="en-US" smtClean="0"/>
               <a:t>Second level</a:t>
             </a:r>
+            <a:endParaRPr lang="en-US" smtClean="0"/>
           </a:p>
           <a:p>
             <a:pPr lvl="2"/>
@@ -2670,6 +2648,7 @@
               <a:rPr lang="en-US" smtClean="0"/>
               <a:t>Third level</a:t>
             </a:r>
+            <a:endParaRPr lang="en-US" smtClean="0"/>
           </a:p>
           <a:p>
             <a:pPr lvl="3"/>
@@ -2677,6 +2656,7 @@
               <a:rPr lang="en-US" smtClean="0"/>
               <a:t>Fourth level</a:t>
             </a:r>
+            <a:endParaRPr lang="en-US" smtClean="0"/>
           </a:p>
           <a:p>
             <a:pPr lvl="4"/>
@@ -2723,7 +2703,6 @@
           <a:p>
             <a:fld id="{5BCAD085-E8A6-8845-BD4E-CB4CCA059FC4}" type="datetimeFigureOut">
               <a:rPr lang="en-US" smtClean="0"/>
-              <a:t>1/27/13</a:t>
             </a:fld>
             <a:endParaRPr lang="en-US"/>
           </a:p>
@@ -2801,18 +2780,12 @@
           <a:p>
             <a:fld id="{C1FF6DA9-008F-8B48-92A6-B652298478BF}" type="slidenum">
               <a:rPr lang="en-US" smtClean="0"/>
-              <a:t>‹#›</a:t>
             </a:fld>
             <a:endParaRPr lang="en-US"/>
           </a:p>
         </p:txBody>
       </p:sp>
     </p:spTree>
-    <p:extLst>
-      <p:ext uri="{BB962C8B-B14F-4D97-AF65-F5344CB8AC3E}">
-        <p14:creationId xmlns:p14="http://schemas.microsoft.com/office/powerpoint/2010/main" val="2209977519"/>
-      </p:ext>
-    </p:extLst>
   </p:cSld>
   <p:clrMap bg1="lt1" tx1="dk1" bg2="lt2" tx2="dk2" accent1="accent1" accent2="accent2" accent3="accent3" accent4="accent4" accent5="accent5" accent6="accent6" hlink="hlink" folHlink="folHlink"/>
   <p:sldLayoutIdLst>
@@ -2850,7 +2823,7 @@
         <a:spcBef>
           <a:spcPct val="20000"/>
         </a:spcBef>
-        <a:buFont typeface="Arial"/>
+        <a:buFont typeface="Arial" panose="020B0604020202090204"/>
         <a:buChar char="•"/>
         <a:defRPr sz="3200" kern="1200">
           <a:solidFill>
@@ -2865,7 +2838,7 @@
         <a:spcBef>
           <a:spcPct val="20000"/>
         </a:spcBef>
-        <a:buFont typeface="Arial"/>
+        <a:buFont typeface="Arial" panose="020B0604020202090204"/>
         <a:buChar char="–"/>
         <a:defRPr sz="2800" kern="1200">
           <a:solidFill>
@@ -2880,7 +2853,7 @@
         <a:spcBef>
           <a:spcPct val="20000"/>
         </a:spcBef>
-        <a:buFont typeface="Arial"/>
+        <a:buFont typeface="Arial" panose="020B0604020202090204"/>
         <a:buChar char="•"/>
         <a:defRPr sz="2400" kern="1200">
           <a:solidFill>
@@ -2895,7 +2868,7 @@
         <a:spcBef>
           <a:spcPct val="20000"/>
         </a:spcBef>
-        <a:buFont typeface="Arial"/>
+        <a:buFont typeface="Arial" panose="020B0604020202090204"/>
         <a:buChar char="–"/>
         <a:defRPr sz="2000" kern="1200">
           <a:solidFill>
@@ -2910,7 +2883,7 @@
         <a:spcBef>
           <a:spcPct val="20000"/>
         </a:spcBef>
-        <a:buFont typeface="Arial"/>
+        <a:buFont typeface="Arial" panose="020B0604020202090204"/>
         <a:buChar char="»"/>
         <a:defRPr sz="2000" kern="1200">
           <a:solidFill>
@@ -2925,7 +2898,7 @@
         <a:spcBef>
           <a:spcPct val="20000"/>
         </a:spcBef>
-        <a:buFont typeface="Arial"/>
+        <a:buFont typeface="Arial" panose="020B0604020202090204"/>
         <a:buChar char="•"/>
         <a:defRPr sz="2000" kern="1200">
           <a:solidFill>
@@ -2940,7 +2913,7 @@
         <a:spcBef>
           <a:spcPct val="20000"/>
         </a:spcBef>
-        <a:buFont typeface="Arial"/>
+        <a:buFont typeface="Arial" panose="020B0604020202090204"/>
         <a:buChar char="•"/>
         <a:defRPr sz="2000" kern="1200">
           <a:solidFill>
@@ -2955,7 +2928,7 @@
         <a:spcBef>
           <a:spcPct val="20000"/>
         </a:spcBef>
-        <a:buFont typeface="Arial"/>
+        <a:buFont typeface="Arial" panose="020B0604020202090204"/>
         <a:buChar char="•"/>
         <a:defRPr sz="2000" kern="1200">
           <a:solidFill>
@@ -2970,7 +2943,7 @@
         <a:spcBef>
           <a:spcPct val="20000"/>
         </a:spcBef>
-        <a:buFont typeface="Arial"/>
+        <a:buFont typeface="Arial" panose="020B0604020202090204"/>
         <a:buChar char="•"/>
         <a:defRPr sz="2000" kern="1200">
           <a:solidFill>
@@ -3082,7 +3055,7 @@
 </file>
 
 <file path=ppt/slides/slide1.xml><?xml version="1.0" encoding="utf-8"?>
-<p:sld xmlns:a="http://schemas.openxmlformats.org/drawingml/2006/main" xmlns:p="http://schemas.openxmlformats.org/presentationml/2006/main" xmlns:r="http://schemas.openxmlformats.org/officeDocument/2006/relationships">
+<p:sld xmlns:a="http://schemas.openxmlformats.org/drawingml/2006/main" xmlns:r="http://schemas.openxmlformats.org/officeDocument/2006/relationships" xmlns:p="http://schemas.openxmlformats.org/presentationml/2006/main">
   <p:cSld>
     <p:bg>
       <p:bgPr>
@@ -3144,14 +3117,14 @@
       </p:sp>
       <p:sp>
         <p:nvSpPr>
-          <p:cNvPr id="3" name="TextBox 2"/>
+          <p:cNvPr id="5" name="TextBox 4"/>
           <p:cNvSpPr txBox="1"/>
           <p:nvPr/>
         </p:nvSpPr>
         <p:spPr>
           <a:xfrm>
-            <a:off x="457200" y="146304"/>
-            <a:ext cx="11338560" cy="475488"/>
+            <a:off x="457200" y="329057"/>
+            <a:ext cx="11247120" cy="384048"/>
           </a:xfrm>
           <a:prstGeom prst="rect">
             <a:avLst/>
@@ -3174,36 +3147,46 @@
               </a:spcAft>
             </a:pPr>
             <a:r>
-              <a:rPr sz="2400" b="1" i="0">
-                <a:solidFill>
-                  <a:srgbClr val="000000"/>
+              <a:rPr sz="1600" b="0" i="0">
+                <a:solidFill>
+                  <a:srgbClr val="333333"/>
                 </a:solidFill>
                 <a:latin typeface="Calibri"/>
               </a:rPr>
-              <a:t>The problems themselves are classical</a:t>
-            </a:r>
-          </a:p>
-        </p:txBody>
-      </p:sp>
-      <p:sp>
-        <p:nvSpPr>
-          <p:cNvPr id="4" name="Rectangle 3"/>
+              <a:t>knapsack and 4-SAT are ordinary combinatorial questions — and NP-complete. A quantum machine can still be the right solver.</a:t>
+            </a:r>
+            <a:endParaRPr sz="1600" b="0" i="0">
+              <a:solidFill>
+                <a:srgbClr val="333333"/>
+              </a:solidFill>
+              <a:latin typeface="Calibri"/>
+            </a:endParaRPr>
+          </a:p>
+        </p:txBody>
+      </p:sp>
+      <p:sp>
+        <p:nvSpPr>
+          <p:cNvPr id="6" name="Rounded Rectangle 5"/>
           <p:cNvSpPr/>
           <p:nvPr/>
         </p:nvSpPr>
         <p:spPr>
           <a:xfrm>
-            <a:off x="457200" y="640080"/>
-            <a:ext cx="11274552" cy="13716"/>
-          </a:xfrm>
-          <a:prstGeom prst="rect">
-            <a:avLst/>
+            <a:off x="457200" y="1170432"/>
+            <a:ext cx="3611880" cy="2944368"/>
+          </a:xfrm>
+          <a:prstGeom prst="roundRect">
+            <a:avLst>
+              <a:gd name="adj" fmla="val 6000"/>
+            </a:avLst>
           </a:prstGeom>
           <a:solidFill>
-            <a:srgbClr val="000000"/>
+            <a:srgbClr val="F4F4F4"/>
           </a:solidFill>
-          <a:ln>
-            <a:noFill/>
+          <a:ln w="6350">
+            <a:solidFill>
+              <a:srgbClr val="D0D0D0"/>
+            </a:solidFill>
           </a:ln>
         </p:spPr>
         <p:style>
@@ -3230,14 +3213,14 @@
       </p:sp>
       <p:sp>
         <p:nvSpPr>
-          <p:cNvPr id="5" name="TextBox 4"/>
+          <p:cNvPr id="7" name="TextBox 6"/>
           <p:cNvSpPr txBox="1"/>
           <p:nvPr/>
         </p:nvSpPr>
         <p:spPr>
           <a:xfrm>
-            <a:off x="457200" y="713232"/>
-            <a:ext cx="11247120" cy="384048"/>
+            <a:off x="603504" y="1280160"/>
+            <a:ext cx="3319272" cy="2724912"/>
           </a:xfrm>
           <a:prstGeom prst="rect">
             <a:avLst/>
@@ -3256,30 +3239,148 @@
                 <a:spcPts val="0"/>
               </a:spcBef>
               <a:spcAft>
+                <a:spcPts val="800"/>
+              </a:spcAft>
+            </a:pPr>
+            <a:r>
+              <a:rPr sz="1600" b="1" i="0">
+                <a:solidFill>
+                  <a:srgbClr val="000000"/>
+                </a:solidFill>
+                <a:latin typeface="Calibri"/>
+              </a:rPr>
+              <a:t>Two textbook problems</a:t>
+            </a:r>
+            <a:endParaRPr sz="1600" b="1" i="0">
+              <a:solidFill>
+                <a:srgbClr val="000000"/>
+              </a:solidFill>
+              <a:latin typeface="Calibri"/>
+            </a:endParaRPr>
+          </a:p>
+          <a:p>
+            <a:pPr>
+              <a:lnSpc>
+                <a:spcPct val="112000"/>
+              </a:lnSpc>
+              <a:spcBef>
+                <a:spcPts val="0"/>
+              </a:spcBef>
+              <a:spcAft>
+                <a:spcPts val="200"/>
+              </a:spcAft>
+            </a:pPr>
+            <a:r>
+              <a:rPr sz="1400" b="1" i="0">
+                <a:solidFill>
+                  <a:srgbClr val="000000"/>
+                </a:solidFill>
+                <a:latin typeface="Calibri"/>
+              </a:rPr>
+              <a:t>0-1 knapsack.</a:t>
+            </a:r>
+            <a:endParaRPr sz="1400" b="1" i="0">
+              <a:solidFill>
+                <a:srgbClr val="000000"/>
+              </a:solidFill>
+              <a:latin typeface="Calibri"/>
+            </a:endParaRPr>
+          </a:p>
+          <a:p>
+            <a:pPr>
+              <a:lnSpc>
+                <a:spcPct val="108000"/>
+              </a:lnSpc>
+              <a:spcBef>
+                <a:spcPts val="0"/>
+              </a:spcBef>
+              <a:spcAft>
+                <a:spcPts val="800"/>
+              </a:spcAft>
+            </a:pPr>
+            <a:r>
+              <a:rPr sz="1300" b="0" i="0">
+                <a:solidFill>
+                  <a:srgbClr val="000000"/>
+                </a:solidFill>
+                <a:latin typeface="Calibri"/>
+              </a:rPr>
+              <a:t>Items with weights and values, a capacity. Can you pack value at least V without overflowing? (Or: pack as much value as possible.)</a:t>
+            </a:r>
+            <a:endParaRPr sz="1300" b="0" i="0">
+              <a:solidFill>
+                <a:srgbClr val="000000"/>
+              </a:solidFill>
+              <a:latin typeface="Calibri"/>
+            </a:endParaRPr>
+          </a:p>
+          <a:p>
+            <a:pPr>
+              <a:lnSpc>
+                <a:spcPct val="112000"/>
+              </a:lnSpc>
+              <a:spcBef>
+                <a:spcPts val="0"/>
+              </a:spcBef>
+              <a:spcAft>
+                <a:spcPts val="200"/>
+              </a:spcAft>
+            </a:pPr>
+            <a:r>
+              <a:rPr sz="1400" b="1" i="0">
+                <a:solidFill>
+                  <a:srgbClr val="000000"/>
+                </a:solidFill>
+                <a:latin typeface="Calibri"/>
+              </a:rPr>
+              <a:t>4-SAT.</a:t>
+            </a:r>
+            <a:endParaRPr sz="1400" b="1" i="0">
+              <a:solidFill>
+                <a:srgbClr val="000000"/>
+              </a:solidFill>
+              <a:latin typeface="Calibri"/>
+            </a:endParaRPr>
+          </a:p>
+          <a:p>
+            <a:pPr>
+              <a:lnSpc>
+                <a:spcPct val="108000"/>
+              </a:lnSpc>
+              <a:spcBef>
+                <a:spcPts val="0"/>
+              </a:spcBef>
+              <a:spcAft>
                 <a:spcPts val="0"/>
               </a:spcAft>
             </a:pPr>
             <a:r>
-              <a:rPr sz="1600" b="0" i="0">
-                <a:solidFill>
-                  <a:srgbClr val="333333"/>
+              <a:rPr sz="1300" b="0" i="0">
+                <a:solidFill>
+                  <a:srgbClr val="000000"/>
                 </a:solidFill>
                 <a:latin typeface="Calibri"/>
               </a:rPr>
-              <a:t>0-1 knapsack and 4-SAT are ordinary combinatorial questions — and NP-complete. A quantum machine can still be the right solver.</a:t>
-            </a:r>
-          </a:p>
-        </p:txBody>
-      </p:sp>
-      <p:sp>
-        <p:nvSpPr>
-          <p:cNvPr id="6" name="Rounded Rectangle 5"/>
+              <a:t>A Boolean formula whose every clause is an OR of four literals. Does any 0/1 assignment make every clause true?</a:t>
+            </a:r>
+            <a:endParaRPr sz="1300" b="0" i="0">
+              <a:solidFill>
+                <a:srgbClr val="000000"/>
+              </a:solidFill>
+              <a:latin typeface="Calibri"/>
+            </a:endParaRPr>
+          </a:p>
+        </p:txBody>
+      </p:sp>
+      <p:sp>
+        <p:nvSpPr>
+          <p:cNvPr id="8" name="Rounded Rectangle 7"/>
           <p:cNvSpPr/>
           <p:nvPr/>
         </p:nvSpPr>
         <p:spPr>
           <a:xfrm>
-            <a:off x="457200" y="1170432"/>
+            <a:off x="4233672" y="1170432"/>
             <a:ext cx="3611880" cy="2944368"/>
           </a:xfrm>
           <a:prstGeom prst="roundRect">
@@ -3320,13 +3421,13 @@
       </p:sp>
       <p:sp>
         <p:nvSpPr>
-          <p:cNvPr id="7" name="TextBox 6"/>
+          <p:cNvPr id="9" name="TextBox 8"/>
           <p:cNvSpPr txBox="1"/>
           <p:nvPr/>
         </p:nvSpPr>
         <p:spPr>
           <a:xfrm>
-            <a:off x="603504" y="1280160"/>
+            <a:off x="4379976" y="1280160"/>
             <a:ext cx="3319272" cy="2724912"/>
           </a:xfrm>
           <a:prstGeom prst="rect">
@@ -3356,30 +3457,14 @@
                 </a:solidFill>
                 <a:latin typeface="Calibri"/>
               </a:rPr>
-              <a:t>Two textbook problems</a:t>
-            </a:r>
-          </a:p>
-          <a:p>
-            <a:pPr>
-              <a:lnSpc>
-                <a:spcPct val="112000"/>
-              </a:lnSpc>
-              <a:spcBef>
-                <a:spcPts val="0"/>
-              </a:spcBef>
-              <a:spcAft>
-                <a:spcPts val="200"/>
-              </a:spcAft>
-            </a:pPr>
-            <a:r>
-              <a:rPr sz="1400" b="1" i="0">
-                <a:solidFill>
-                  <a:srgbClr val="000000"/>
-                </a:solidFill>
-                <a:latin typeface="Calibri"/>
-              </a:rPr>
-              <a:t>0-1 knapsack.</a:t>
-            </a:r>
+              <a:t>NP-complete, in plain words</a:t>
+            </a:r>
+            <a:endParaRPr sz="1600" b="1" i="0">
+              <a:solidFill>
+                <a:srgbClr val="000000"/>
+              </a:solidFill>
+              <a:latin typeface="Calibri"/>
+            </a:endParaRPr>
           </a:p>
           <a:p>
             <a:pPr>
@@ -3390,7 +3475,7 @@
                 <a:spcPts val="0"/>
               </a:spcBef>
               <a:spcAft>
-                <a:spcPts val="800"/>
+                <a:spcPts val="700"/>
               </a:spcAft>
             </a:pPr>
             <a:r>
@@ -3400,30 +3485,42 @@
                 </a:solidFill>
                 <a:latin typeface="Calibri"/>
               </a:rPr>
-              <a:t>Items with weights and values, a capacity. Can you pack value at least V without overflowing? (Or: pack as much value as possible.)</a:t>
-            </a:r>
+              <a:t>NP: a proposed answer can be checked quickly (polynomial time).</a:t>
+            </a:r>
+            <a:endParaRPr sz="1300" b="0" i="0">
+              <a:solidFill>
+                <a:srgbClr val="000000"/>
+              </a:solidFill>
+              <a:latin typeface="Calibri"/>
+            </a:endParaRPr>
           </a:p>
           <a:p>
             <a:pPr>
               <a:lnSpc>
-                <a:spcPct val="112000"/>
+                <a:spcPct val="108000"/>
               </a:lnSpc>
               <a:spcBef>
                 <a:spcPts val="0"/>
               </a:spcBef>
               <a:spcAft>
-                <a:spcPts val="200"/>
+                <a:spcPts val="700"/>
               </a:spcAft>
             </a:pPr>
             <a:r>
-              <a:rPr sz="1400" b="1" i="0">
+              <a:rPr sz="1300" b="0" i="0">
                 <a:solidFill>
                   <a:srgbClr val="000000"/>
                 </a:solidFill>
                 <a:latin typeface="Calibri"/>
               </a:rPr>
-              <a:t>4-SAT.</a:t>
-            </a:r>
+              <a:t>NP-complete: the hardest problems in NP. Every other NP problem can be rewritten as one of them in polynomial time.</a:t>
+            </a:r>
+            <a:endParaRPr sz="1300" b="0" i="0">
+              <a:solidFill>
+                <a:srgbClr val="000000"/>
+              </a:solidFill>
+              <a:latin typeface="Calibri"/>
+            </a:endParaRPr>
           </a:p>
           <a:p>
             <a:pPr>
@@ -3444,21 +3541,27 @@
                 </a:solidFill>
                 <a:latin typeface="Calibri"/>
               </a:rPr>
-              <a:t>A Boolean formula whose every clause is an OR of four literals. Does any 0/1 assignment make every clause true?</a:t>
-            </a:r>
-          </a:p>
-        </p:txBody>
-      </p:sp>
-      <p:sp>
-        <p:nvSpPr>
-          <p:cNvPr id="8" name="Rounded Rectangle 7"/>
+              <a:t>Easy to verify, believed hard to find. A fast algorithm for any one of them would give a fast algorithm for all of NP.</a:t>
+            </a:r>
+            <a:endParaRPr sz="1300" b="0" i="0">
+              <a:solidFill>
+                <a:srgbClr val="000000"/>
+              </a:solidFill>
+              <a:latin typeface="Calibri"/>
+            </a:endParaRPr>
+          </a:p>
+        </p:txBody>
+      </p:sp>
+      <p:sp>
+        <p:nvSpPr>
+          <p:cNvPr id="10" name="Rounded Rectangle 9"/>
           <p:cNvSpPr/>
           <p:nvPr/>
         </p:nvSpPr>
         <p:spPr>
           <a:xfrm>
-            <a:off x="4233672" y="1170432"/>
-            <a:ext cx="3611880" cy="2944368"/>
+            <a:off x="8010144" y="1170432"/>
+            <a:ext cx="3721608" cy="2944368"/>
           </a:xfrm>
           <a:prstGeom prst="roundRect">
             <a:avLst>
@@ -3498,14 +3601,14 @@
       </p:sp>
       <p:sp>
         <p:nvSpPr>
-          <p:cNvPr id="9" name="TextBox 8"/>
+          <p:cNvPr id="11" name="TextBox 10"/>
           <p:cNvSpPr txBox="1"/>
           <p:nvPr/>
         </p:nvSpPr>
         <p:spPr>
           <a:xfrm>
-            <a:off x="4379976" y="1280160"/>
-            <a:ext cx="3319272" cy="2724912"/>
+            <a:off x="8156448" y="1280160"/>
+            <a:ext cx="3429000" cy="2724912"/>
           </a:xfrm>
           <a:prstGeom prst="rect">
             <a:avLst/>
@@ -3534,8 +3637,14 @@
                 </a:solidFill>
                 <a:latin typeface="Calibri"/>
               </a:rPr>
-              <a:t>NP-complete, in plain words</a:t>
-            </a:r>
+              <a:t>Why a quantum machine can still help</a:t>
+            </a:r>
+            <a:endParaRPr sz="1600" b="1" i="0">
+              <a:solidFill>
+                <a:srgbClr val="000000"/>
+              </a:solidFill>
+              <a:latin typeface="Calibri"/>
+            </a:endParaRPr>
           </a:p>
           <a:p>
             <a:pPr>
@@ -3556,30 +3665,32 @@
                 </a:solidFill>
                 <a:latin typeface="Calibri"/>
               </a:rPr>
-              <a:t>NP: a proposed answer can be checked quickly (polynomial time).</a:t>
-            </a:r>
-          </a:p>
-          <a:p>
-            <a:pPr>
-              <a:lnSpc>
-                <a:spcPct val="108000"/>
-              </a:lnSpc>
-              <a:spcBef>
-                <a:spcPts val="0"/>
-              </a:spcBef>
-              <a:spcAft>
-                <a:spcPts val="700"/>
-              </a:spcAft>
-            </a:pPr>
-            <a:r>
-              <a:rPr sz="1300" b="0" i="0">
+              <a:t>Turn the cost into a Hamiltonian. Variational </a:t>
+            </a:r>
+            <a:r>
+              <a:rPr lang="en-US" sz="1300" b="0" i="0">
                 <a:solidFill>
                   <a:srgbClr val="000000"/>
                 </a:solidFill>
                 <a:latin typeface="Calibri"/>
               </a:rPr>
-              <a:t>NP-complete: the hardest problems in NP. Every other NP problem can be rewritten as one of them in polynomial time.</a:t>
-            </a:r>
+              <a:t>or </a:t>
+            </a:r>
+            <a:r>
+              <a:rPr sz="1300" b="0" i="0">
+                <a:solidFill>
+                  <a:srgbClr val="000000"/>
+                </a:solidFill>
+                <a:latin typeface="Calibri"/>
+              </a:rPr>
+              <a:t>adiabatic algorithms search that landscape in superposition.</a:t>
+            </a:r>
+            <a:endParaRPr sz="1300" b="0" i="0">
+              <a:solidFill>
+                <a:srgbClr val="000000"/>
+              </a:solidFill>
+              <a:latin typeface="Calibri"/>
+            </a:endParaRPr>
           </a:p>
           <a:p>
             <a:pPr>
@@ -3600,21 +3711,27 @@
                 </a:solidFill>
                 <a:latin typeface="Calibri"/>
               </a:rPr>
-              <a:t>Easy to verify, believed hard to find. A fast algorithm for any one of them would give a fast algorithm for all of NP.</a:t>
-            </a:r>
-          </a:p>
-        </p:txBody>
-      </p:sp>
-      <p:sp>
-        <p:nvSpPr>
-          <p:cNvPr id="10" name="Rounded Rectangle 9"/>
+              <a:t>For SAT-type problems, that is already showing empirical scaling gains — next slide.</a:t>
+            </a:r>
+            <a:endParaRPr sz="1300" b="0" i="0">
+              <a:solidFill>
+                <a:srgbClr val="000000"/>
+              </a:solidFill>
+              <a:latin typeface="Calibri"/>
+            </a:endParaRPr>
+          </a:p>
+        </p:txBody>
+      </p:sp>
+      <p:sp>
+        <p:nvSpPr>
+          <p:cNvPr id="12" name="Rounded Rectangle 11"/>
           <p:cNvSpPr/>
           <p:nvPr/>
         </p:nvSpPr>
         <p:spPr>
           <a:xfrm>
-            <a:off x="8010144" y="1170432"/>
-            <a:ext cx="3721608" cy="2944368"/>
+            <a:off x="457200" y="4242816"/>
+            <a:ext cx="11274552" cy="2267712"/>
           </a:xfrm>
           <a:prstGeom prst="roundRect">
             <a:avLst>
@@ -3654,14 +3771,14 @@
       </p:sp>
       <p:sp>
         <p:nvSpPr>
-          <p:cNvPr id="11" name="TextBox 10"/>
+          <p:cNvPr id="13" name="TextBox 12"/>
           <p:cNvSpPr txBox="1"/>
           <p:nvPr/>
         </p:nvSpPr>
         <p:spPr>
           <a:xfrm>
-            <a:off x="8156448" y="1280160"/>
-            <a:ext cx="3429000" cy="2724912"/>
+            <a:off x="640080" y="4352544"/>
+            <a:ext cx="10972800" cy="2011680"/>
           </a:xfrm>
           <a:prstGeom prst="rect">
             <a:avLst/>
@@ -3690,143 +3807,15 @@
                 </a:solidFill>
                 <a:latin typeface="Calibri"/>
               </a:rPr>
-              <a:t>Why a quantum machine can still help</a:t>
-            </a:r>
-          </a:p>
-          <a:p>
-            <a:pPr>
-              <a:lnSpc>
-                <a:spcPct val="108000"/>
-              </a:lnSpc>
-              <a:spcBef>
-                <a:spcPts val="0"/>
-              </a:spcBef>
-              <a:spcAft>
-                <a:spcPts val="700"/>
-              </a:spcAft>
-            </a:pPr>
-            <a:r>
-              <a:rPr sz="1300" b="0" i="0">
-                <a:solidFill>
-                  <a:srgbClr val="000000"/>
-                </a:solidFill>
-                <a:latin typeface="Calibri"/>
-              </a:rPr>
-              <a:t>NP-completeness is a classical worst-case label. It does not forbid better typical-case scaling, or a more compact encoding on quantum hardware.</a:t>
-            </a:r>
-          </a:p>
-          <a:p>
-            <a:pPr>
-              <a:lnSpc>
-                <a:spcPct val="108000"/>
-              </a:lnSpc>
-              <a:spcBef>
-                <a:spcPts val="0"/>
-              </a:spcBef>
-              <a:spcAft>
-                <a:spcPts val="700"/>
-              </a:spcAft>
-            </a:pPr>
-            <a:r>
-              <a:rPr sz="1300" b="0" i="0">
-                <a:solidFill>
-                  <a:srgbClr val="000000"/>
-                </a:solidFill>
-                <a:latin typeface="Calibri"/>
-              </a:rPr>
-              <a:t>Turn the cost into a Hamiltonian. Variational and adiabatic algorithms search that landscape in superposition.</a:t>
-            </a:r>
-          </a:p>
-          <a:p>
-            <a:pPr>
-              <a:lnSpc>
-                <a:spcPct val="108000"/>
-              </a:lnSpc>
-              <a:spcBef>
-                <a:spcPts val="0"/>
-              </a:spcBef>
-              <a:spcAft>
-                <a:spcPts val="0"/>
-              </a:spcAft>
-            </a:pPr>
-            <a:r>
-              <a:rPr sz="1300" b="0" i="0">
-                <a:solidFill>
-                  <a:srgbClr val="000000"/>
-                </a:solidFill>
-                <a:latin typeface="Calibri"/>
-              </a:rPr>
-              <a:t>For SAT-type problems, that is already showing empirical scaling gains — next slide.</a:t>
-            </a:r>
-          </a:p>
-        </p:txBody>
-      </p:sp>
-      <p:sp>
-        <p:nvSpPr>
-          <p:cNvPr id="12" name="Rounded Rectangle 11"/>
-          <p:cNvSpPr/>
-          <p:nvPr/>
-        </p:nvSpPr>
-        <p:spPr>
-          <a:xfrm>
-            <a:off x="457200" y="4242816"/>
-            <a:ext cx="11274552" cy="2267712"/>
-          </a:xfrm>
-          <a:prstGeom prst="roundRect">
-            <a:avLst>
-              <a:gd name="adj" fmla="val 6000"/>
-            </a:avLst>
-          </a:prstGeom>
-          <a:solidFill>
-            <a:srgbClr val="F4F4F4"/>
-          </a:solidFill>
-          <a:ln w="6350">
-            <a:solidFill>
-              <a:srgbClr val="D0D0D0"/>
-            </a:solidFill>
-          </a:ln>
-        </p:spPr>
-        <p:style>
-          <a:lnRef idx="1">
-            <a:schemeClr val="accent1"/>
-          </a:lnRef>
-          <a:fillRef idx="3">
-            <a:schemeClr val="accent1"/>
-          </a:fillRef>
-          <a:effectRef idx="2">
-            <a:schemeClr val="accent1"/>
-          </a:effectRef>
-          <a:fontRef idx="minor">
-            <a:schemeClr val="lt1"/>
-          </a:fontRef>
-        </p:style>
-        <p:txBody>
-          <a:bodyPr rtlCol="0" anchor="ctr"/>
-          <a:lstStyle/>
-          <a:p>
-            <a:pPr algn="ctr"/>
-          </a:p>
-        </p:txBody>
-      </p:sp>
-      <p:sp>
-        <p:nvSpPr>
-          <p:cNvPr id="13" name="TextBox 12"/>
-          <p:cNvSpPr txBox="1"/>
-          <p:nvPr/>
-        </p:nvSpPr>
-        <p:spPr>
-          <a:xfrm>
-            <a:off x="640080" y="4352544"/>
-            <a:ext cx="10972800" cy="2011680"/>
-          </a:xfrm>
-          <a:prstGeom prst="rect">
-            <a:avLst/>
-          </a:prstGeom>
-          <a:noFill/>
-        </p:spPr>
-        <p:txBody>
-          <a:bodyPr wrap="square"/>
-          <a:lstStyle/>
+              <a:t>Previous work chose knapsack. We choose 4-SAT.</a:t>
+            </a:r>
+            <a:endParaRPr sz="1600" b="1" i="0">
+              <a:solidFill>
+                <a:srgbClr val="000000"/>
+              </a:solidFill>
+              <a:latin typeface="Calibri"/>
+            </a:endParaRPr>
+          </a:p>
           <a:p>
             <a:pPr>
               <a:lnSpc>
@@ -3840,28 +3829,6 @@
               </a:spcAft>
             </a:pPr>
             <a:r>
-              <a:rPr sz="1600" b="1" i="0">
-                <a:solidFill>
-                  <a:srgbClr val="000000"/>
-                </a:solidFill>
-                <a:latin typeface="Calibri"/>
-              </a:rPr>
-              <a:t>Previous work chose knapsack. We choose 4-SAT.</a:t>
-            </a:r>
-          </a:p>
-          <a:p>
-            <a:pPr>
-              <a:lnSpc>
-                <a:spcPct val="112000"/>
-              </a:lnSpc>
-              <a:spcBef>
-                <a:spcPts val="0"/>
-              </a:spcBef>
-              <a:spcAft>
-                <a:spcPts val="800"/>
-              </a:spcAft>
-            </a:pPr>
-            <a:r>
               <a:rPr sz="1400" b="1" i="0">
                 <a:solidFill>
                   <a:srgbClr val="000000"/>
@@ -3903,10 +3870,16 @@
                   <a:srgbClr val="333333"/>
                 </a:solidFill>
                 <a:latin typeface="Calibri"/>
-                <a:hlinkClick r:id="rId2"/>
+                <a:hlinkClick r:id="rId1"/>
               </a:rPr>
               <a:t>https://arxiv.org/abs/2501.11735</a:t>
             </a:r>
+            <a:endParaRPr sz="1400" b="0" i="0">
+              <a:solidFill>
+                <a:srgbClr val="333333"/>
+              </a:solidFill>
+              <a:latin typeface="Calibri"/>
+            </a:endParaRPr>
           </a:p>
           <a:p>
             <a:pPr>
@@ -3956,6 +3929,12 @@
               </a:rPr>
               <a:t>.</a:t>
             </a:r>
+            <a:endParaRPr sz="1400" b="0" i="0">
+              <a:solidFill>
+                <a:srgbClr val="000000"/>
+              </a:solidFill>
+              <a:latin typeface="Calibri"/>
+            </a:endParaRPr>
           </a:p>
         </p:txBody>
       </p:sp>
@@ -3968,7 +3947,7 @@
 </file>
 
 <file path=ppt/slides/slide2.xml><?xml version="1.0" encoding="utf-8"?>
-<p:sld xmlns:a="http://schemas.openxmlformats.org/drawingml/2006/main" xmlns:p="http://schemas.openxmlformats.org/presentationml/2006/main" xmlns:r="http://schemas.openxmlformats.org/officeDocument/2006/relationships">
+<p:sld xmlns:a="http://schemas.openxmlformats.org/drawingml/2006/main" xmlns:r="http://schemas.openxmlformats.org/officeDocument/2006/relationships" xmlns:p="http://schemas.openxmlformats.org/presentationml/2006/main">
   <p:cSld>
     <p:bg>
       <p:bgPr>
@@ -4068,6 +4047,12 @@
               </a:rPr>
               <a:t>Empirical support: quantum SAT solvers can still win</a:t>
             </a:r>
+            <a:endParaRPr sz="2400" b="1" i="0">
+              <a:solidFill>
+                <a:srgbClr val="000000"/>
+              </a:solidFill>
+              <a:latin typeface="Calibri"/>
+            </a:endParaRPr>
           </a:p>
         </p:txBody>
       </p:sp>
@@ -4154,6 +4139,12 @@
               </a:rPr>
               <a:t>Lu, Wei, Li, Gao, Yan, Zheng, Zhang, Zeng, Long, et al.  </a:t>
             </a:r>
+            <a:endParaRPr sz="1400" b="1" i="0">
+              <a:solidFill>
+                <a:srgbClr val="000000"/>
+              </a:solidFill>
+              <a:latin typeface="Calibri"/>
+            </a:endParaRPr>
           </a:p>
           <a:p>
             <a:pPr>
@@ -4185,6 +4176,12 @@
               </a:rPr>
               <a:t>Nat. Comput. Sci. 6, 882–893 (2026).</a:t>
             </a:r>
+            <a:endParaRPr sz="1400" b="0" i="0">
+              <a:solidFill>
+                <a:srgbClr val="000000"/>
+              </a:solidFill>
+              <a:latin typeface="Calibri"/>
+            </a:endParaRPr>
           </a:p>
         </p:txBody>
       </p:sp>
@@ -4275,6 +4272,12 @@
               </a:rPr>
               <a:t>“Without complexity proofs, scaling advantage — where quantum resource requirements grow more slowly than their classical counterparts — is the primary indicator.”</a:t>
             </a:r>
+            <a:endParaRPr sz="1500" b="0" i="1">
+              <a:solidFill>
+                <a:srgbClr val="000000"/>
+              </a:solidFill>
+              <a:latin typeface="Calibri"/>
+            </a:endParaRPr>
           </a:p>
           <a:p>
             <a:pPr>
@@ -4297,6 +4300,12 @@
               </a:rPr>
               <a:t>They report empirical evidence of quantum speedup on an NP-complete SAT problem. That is the argument that a quantum machine can still be beneficial here.</a:t>
             </a:r>
+            <a:endParaRPr sz="1400" b="0" i="0">
+              <a:solidFill>
+                <a:srgbClr val="000000"/>
+              </a:solidFill>
+              <a:latin typeface="Calibri"/>
+            </a:endParaRPr>
           </a:p>
         </p:txBody>
       </p:sp>
@@ -4387,6 +4396,12 @@
               </a:rPr>
               <a:t>What they did</a:t>
             </a:r>
+            <a:endParaRPr sz="1600" b="1" i="0">
+              <a:solidFill>
+                <a:srgbClr val="000000"/>
+              </a:solidFill>
+              <a:latin typeface="Calibri"/>
+            </a:endParaRPr>
           </a:p>
           <a:p>
             <a:pPr>
@@ -4409,6 +4424,12 @@
               </a:rPr>
               <a:t>Target: one-in-three SAT, an NP-complete cousin of 3-SAT. Each clause is true iff exactly one of its three literals is true.</a:t>
             </a:r>
+            <a:endParaRPr sz="1300" b="0" i="0">
+              <a:solidFill>
+                <a:srgbClr val="000000"/>
+              </a:solidFill>
+              <a:latin typeface="Calibri"/>
+            </a:endParaRPr>
           </a:p>
           <a:p>
             <a:pPr>
@@ -4431,6 +4452,12 @@
               </a:rPr>
               <a:t>They built enhanced QAOA and QAA solvers, with a classical space-reduction step, and compared scaling to state-of-the-art classical SAT solvers.</a:t>
             </a:r>
+            <a:endParaRPr sz="1300" b="0" i="0">
+              <a:solidFill>
+                <a:srgbClr val="000000"/>
+              </a:solidFill>
+              <a:latin typeface="Calibri"/>
+            </a:endParaRPr>
           </a:p>
           <a:p>
             <a:pPr>
@@ -4453,6 +4480,12 @@
               </a:rPr>
               <a:t>A 13-qubit superconducting experiment solved instances with 22 variables and matched the predicted improvement.</a:t>
             </a:r>
+            <a:endParaRPr sz="1300" b="0" i="0">
+              <a:solidFill>
+                <a:srgbClr val="000000"/>
+              </a:solidFill>
+              <a:latin typeface="Calibri"/>
+            </a:endParaRPr>
           </a:p>
           <a:p>
             <a:pPr>
@@ -4475,6 +4508,12 @@
               </a:rPr>
               <a:t>Different SAT variant than our 4-SAT. Same moral: NP-complete SAT is a live target for new quantum algorithms.</a:t>
             </a:r>
+            <a:endParaRPr sz="1300" b="0" i="0">
+              <a:solidFill>
+                <a:srgbClr val="000000"/>
+              </a:solidFill>
+              <a:latin typeface="Calibri"/>
+            </a:endParaRPr>
           </a:p>
         </p:txBody>
       </p:sp>
@@ -4565,6 +4604,12 @@
               </a:rPr>
               <a:t>Scaling at the critical ratio m/n = 0.626, n ≤ 70</a:t>
             </a:r>
+            <a:endParaRPr sz="1500" b="1" i="0">
+              <a:solidFill>
+                <a:srgbClr val="000000"/>
+              </a:solidFill>
+              <a:latin typeface="Calibri"/>
+            </a:endParaRPr>
           </a:p>
           <a:p>
             <a:pPr>
@@ -4587,6 +4632,12 @@
               </a:rPr>
               <a:t>Inverse success probability (quantum) vs. solver work (classical).</a:t>
             </a:r>
+            <a:endParaRPr sz="1300" b="0" i="0">
+              <a:solidFill>
+                <a:srgbClr val="333333"/>
+              </a:solidFill>
+              <a:latin typeface="Calibri"/>
+            </a:endParaRPr>
           </a:p>
         </p:txBody>
       </p:sp>
@@ -4599,7 +4650,7 @@
           <p:nvPr/>
         </p:nvPicPr>
         <p:blipFill>
-          <a:blip r:embed="rId2"/>
+          <a:blip r:embed="rId1"/>
           <a:stretch>
             <a:fillRect/>
           </a:stretch>
@@ -4654,6 +4705,12 @@
               </a:rPr>
               <a:t>Both enhanced quantum solvers beat 1.0128ⁿ from the best classical baselines they report.</a:t>
             </a:r>
+            <a:endParaRPr sz="1300" b="0" i="0">
+              <a:solidFill>
+                <a:srgbClr val="000000"/>
+              </a:solidFill>
+              <a:latin typeface="Calibri"/>
+            </a:endParaRPr>
           </a:p>
         </p:txBody>
       </p:sp>
@@ -4694,10 +4751,17 @@
                   <a:srgbClr val="333333"/>
                 </a:solidFill>
                 <a:latin typeface="Calibri"/>
-                <a:hlinkClick r:id="rId3"/>
+                <a:hlinkClick r:id="rId2"/>
               </a:rPr>
               <a:t>https://www.nature.com/articles/s43588-026-01007-8</a:t>
             </a:r>
+            <a:endParaRPr sz="1200" b="0" i="0">
+              <a:solidFill>
+                <a:srgbClr val="333333"/>
+              </a:solidFill>
+              <a:latin typeface="Calibri"/>
+              <a:hlinkClick r:id="rId2"/>
+            </a:endParaRPr>
           </a:p>
         </p:txBody>
       </p:sp>
@@ -4710,7 +4774,7 @@
 </file>
 
 <file path=ppt/slides/slide3.xml><?xml version="1.0" encoding="utf-8"?>
-<p:sld xmlns:a="http://schemas.openxmlformats.org/drawingml/2006/main" xmlns:p="http://schemas.openxmlformats.org/presentationml/2006/main" xmlns:r="http://schemas.openxmlformats.org/officeDocument/2006/relationships">
+<p:sld xmlns:a="http://schemas.openxmlformats.org/drawingml/2006/main" xmlns:r="http://schemas.openxmlformats.org/officeDocument/2006/relationships" xmlns:p="http://schemas.openxmlformats.org/presentationml/2006/main">
   <p:cSld>
     <p:bg>
       <p:bgPr>
@@ -4810,6 +4874,12 @@
               </a:rPr>
               <a:t>What 4-SAT is</a:t>
             </a:r>
+            <a:endParaRPr sz="2400" b="1" i="0">
+              <a:solidFill>
+                <a:srgbClr val="000000"/>
+              </a:solidFill>
+              <a:latin typeface="Calibri"/>
+            </a:endParaRPr>
           </a:p>
         </p:txBody>
       </p:sp>
@@ -4896,6 +4966,12 @@
               </a:rPr>
               <a:t>A 4-SAT instance is a Boolean formula in conjunctive normal form in which every clause has exactly four literals. A literal is a variable or its negation. The formula is satisfiable if some assignment in {0,1}ⁿ makes every clause true.</a:t>
             </a:r>
+            <a:endParaRPr sz="1500" b="0" i="0">
+              <a:solidFill>
+                <a:srgbClr val="000000"/>
+              </a:solidFill>
+              <a:latin typeface="Calibri"/>
+            </a:endParaRPr>
           </a:p>
           <a:p>
             <a:pPr>
@@ -4918,12 +4994,91 @@
               </a:rPr>
               <a:t>SAT was the first NP-complete problem (Cook–Levin). For every k ≥ 3, k-SAT stays NP-complete — 4-SAT included.</a:t>
             </a:r>
+            <a:endParaRPr sz="1500" b="0" i="0">
+              <a:solidFill>
+                <a:srgbClr val="000000"/>
+              </a:solidFill>
+              <a:latin typeface="Calibri"/>
+            </a:endParaRPr>
           </a:p>
         </p:txBody>
       </p:sp>
       <p:pic>
         <p:nvPicPr>
           <p:cNvPr id="6" name="Picture 5" descr="sat_def.png"/>
+          <p:cNvPicPr>
+            <a:picLocks noChangeAspect="1"/>
+          </p:cNvPicPr>
+          <p:nvPr/>
+        </p:nvPicPr>
+        <p:blipFill>
+          <a:blip r:embed="rId1"/>
+          <a:stretch>
+            <a:fillRect/>
+          </a:stretch>
+        </p:blipFill>
+        <p:spPr>
+          <a:xfrm>
+            <a:off x="411480" y="1444752"/>
+            <a:ext cx="6882434" cy="1332484"/>
+          </a:xfrm>
+          <a:prstGeom prst="rect">
+            <a:avLst/>
+          </a:prstGeom>
+        </p:spPr>
+      </p:pic>
+      <p:sp>
+        <p:nvSpPr>
+          <p:cNvPr id="7" name="TextBox 6"/>
+          <p:cNvSpPr txBox="1"/>
+          <p:nvPr/>
+        </p:nvSpPr>
+        <p:spPr>
+          <a:xfrm>
+            <a:off x="457200" y="2868675"/>
+            <a:ext cx="11247120" cy="365760"/>
+          </a:xfrm>
+          <a:prstGeom prst="rect">
+            <a:avLst/>
+          </a:prstGeom>
+          <a:noFill/>
+        </p:spPr>
+        <p:txBody>
+          <a:bodyPr wrap="square"/>
+          <a:lstStyle/>
+          <a:p>
+            <a:pPr>
+              <a:lnSpc>
+                <a:spcPct val="112000"/>
+              </a:lnSpc>
+              <a:spcBef>
+                <a:spcPts val="0"/>
+              </a:spcBef>
+              <a:spcAft>
+                <a:spcPts val="0"/>
+              </a:spcAft>
+            </a:pPr>
+            <a:r>
+              <a:rPr sz="1500" b="1" i="0">
+                <a:solidFill>
+                  <a:srgbClr val="000000"/>
+                </a:solidFill>
+                <a:latin typeface="Calibri"/>
+              </a:rPr>
+              <a:t>Running example: Hamiltonians/four_sat/four_sat_000  —  7 variables, 18 clauses, unique satisfying assignment.</a:t>
+            </a:r>
+            <a:endParaRPr sz="1500" b="1" i="0">
+              <a:solidFill>
+                <a:srgbClr val="000000"/>
+              </a:solidFill>
+              <a:latin typeface="Calibri"/>
+            </a:endParaRPr>
+          </a:p>
+        </p:txBody>
+      </p:sp>
+      <p:pic>
+        <p:nvPicPr>
+          <p:cNvPr id="8" name="Picture 7" descr="sat_catalog.png"/>
           <p:cNvPicPr>
             <a:picLocks noChangeAspect="1"/>
           </p:cNvPicPr>
@@ -4937,60 +5092,17 @@
         </p:blipFill>
         <p:spPr>
           <a:xfrm>
-            <a:off x="411480" y="1444752"/>
-            <a:ext cx="6882434" cy="1332484"/>
+            <a:off x="411480" y="3252723"/>
+            <a:ext cx="11155680" cy="2859770"/>
           </a:xfrm>
           <a:prstGeom prst="rect">
             <a:avLst/>
           </a:prstGeom>
         </p:spPr>
       </p:pic>
-      <p:sp>
-        <p:nvSpPr>
-          <p:cNvPr id="7" name="TextBox 6"/>
-          <p:cNvSpPr txBox="1"/>
-          <p:nvPr/>
-        </p:nvSpPr>
-        <p:spPr>
-          <a:xfrm>
-            <a:off x="457200" y="2868675"/>
-            <a:ext cx="11247120" cy="365760"/>
-          </a:xfrm>
-          <a:prstGeom prst="rect">
-            <a:avLst/>
-          </a:prstGeom>
-          <a:noFill/>
-        </p:spPr>
-        <p:txBody>
-          <a:bodyPr wrap="square"/>
-          <a:lstStyle/>
-          <a:p>
-            <a:pPr>
-              <a:lnSpc>
-                <a:spcPct val="112000"/>
-              </a:lnSpc>
-              <a:spcBef>
-                <a:spcPts val="0"/>
-              </a:spcBef>
-              <a:spcAft>
-                <a:spcPts val="0"/>
-              </a:spcAft>
-            </a:pPr>
-            <a:r>
-              <a:rPr sz="1500" b="1" i="0">
-                <a:solidFill>
-                  <a:srgbClr val="000000"/>
-                </a:solidFill>
-                <a:latin typeface="Calibri"/>
-              </a:rPr>
-              <a:t>Running example: Hamiltonians/four_sat/four_sat_000  —  7 variables, 18 clauses, unique satisfying assignment.</a:t>
-            </a:r>
-          </a:p>
-        </p:txBody>
-      </p:sp>
       <p:pic>
         <p:nvPicPr>
-          <p:cNvPr id="8" name="Picture 7" descr="sat_catalog.png"/>
+          <p:cNvPr id="9" name="Picture 8" descr="sat_gs.png"/>
           <p:cNvPicPr>
             <a:picLocks noChangeAspect="1"/>
           </p:cNvPicPr>
@@ -5004,30 +5116,6 @@
         </p:blipFill>
         <p:spPr>
           <a:xfrm>
-            <a:off x="411480" y="3252723"/>
-            <a:ext cx="11155680" cy="2859770"/>
-          </a:xfrm>
-          <a:prstGeom prst="rect">
-            <a:avLst/>
-          </a:prstGeom>
-        </p:spPr>
-      </p:pic>
-      <p:pic>
-        <p:nvPicPr>
-          <p:cNvPr id="9" name="Picture 8" descr="sat_gs.png"/>
-          <p:cNvPicPr>
-            <a:picLocks noChangeAspect="1"/>
-          </p:cNvPicPr>
-          <p:nvPr/>
-        </p:nvPicPr>
-        <p:blipFill>
-          <a:blip r:embed="rId4"/>
-          <a:stretch>
-            <a:fillRect/>
-          </a:stretch>
-        </p:blipFill>
-        <p:spPr>
-          <a:xfrm>
             <a:off x="411480" y="6185646"/>
             <a:ext cx="11155680" cy="591443"/>
           </a:xfrm>
@@ -5045,7 +5133,7 @@
 </file>
 
 <file path=ppt/slides/slide4.xml><?xml version="1.0" encoding="utf-8"?>
-<p:sld xmlns:a="http://schemas.openxmlformats.org/drawingml/2006/main" xmlns:p="http://schemas.openxmlformats.org/presentationml/2006/main" xmlns:r="http://schemas.openxmlformats.org/officeDocument/2006/relationships">
+<p:sld xmlns:a="http://schemas.openxmlformats.org/drawingml/2006/main" xmlns:r="http://schemas.openxmlformats.org/officeDocument/2006/relationships" xmlns:p="http://schemas.openxmlformats.org/presentationml/2006/main">
   <p:cSld>
     <p:bg>
       <p:bgPr>
@@ -5145,6 +5233,12 @@
               </a:rPr>
               <a:t>From four_sat_000 to a spin Hamiltonian</a:t>
             </a:r>
+            <a:endParaRPr sz="2400" b="1" i="0">
+              <a:solidFill>
+                <a:srgbClr val="000000"/>
+              </a:solidFill>
+              <a:latin typeface="Calibri"/>
+            </a:endParaRPr>
           </a:p>
         </p:txBody>
       </p:sp>
@@ -5231,12 +5325,91 @@
               </a:rPr>
               <a:t>Three steps. Rewrite each clause as a 0/1 penalty, add the penalties, then replace every bit by a Pauli Z. We never write the fully expanded Hamiltonian.</a:t>
             </a:r>
+            <a:endParaRPr sz="1500" b="0" i="0">
+              <a:solidFill>
+                <a:srgbClr val="000000"/>
+              </a:solidFill>
+              <a:latin typeface="Calibri"/>
+            </a:endParaRPr>
           </a:p>
         </p:txBody>
       </p:sp>
       <p:pic>
         <p:nvPicPr>
           <p:cNvPr id="6" name="Picture 5" descr="map_steps.png"/>
+          <p:cNvPicPr>
+            <a:picLocks noChangeAspect="1"/>
+          </p:cNvPicPr>
+          <p:nvPr/>
+        </p:nvPicPr>
+        <p:blipFill>
+          <a:blip r:embed="rId1"/>
+          <a:stretch>
+            <a:fillRect/>
+          </a:stretch>
+        </p:blipFill>
+        <p:spPr>
+          <a:xfrm>
+            <a:off x="365760" y="1259205"/>
+            <a:ext cx="7164070" cy="2390140"/>
+          </a:xfrm>
+          <a:prstGeom prst="rect">
+            <a:avLst/>
+          </a:prstGeom>
+        </p:spPr>
+      </p:pic>
+      <p:sp>
+        <p:nvSpPr>
+          <p:cNvPr id="7" name="TextBox 6"/>
+          <p:cNvSpPr txBox="1"/>
+          <p:nvPr/>
+        </p:nvSpPr>
+        <p:spPr>
+          <a:xfrm>
+            <a:off x="457200" y="3722928"/>
+            <a:ext cx="11247120" cy="292608"/>
+          </a:xfrm>
+          <a:prstGeom prst="rect">
+            <a:avLst/>
+          </a:prstGeom>
+          <a:noFill/>
+        </p:spPr>
+        <p:txBody>
+          <a:bodyPr wrap="square"/>
+          <a:lstStyle/>
+          <a:p>
+            <a:pPr>
+              <a:lnSpc>
+                <a:spcPct val="112000"/>
+              </a:lnSpc>
+              <a:spcBef>
+                <a:spcPts val="0"/>
+              </a:spcBef>
+              <a:spcAft>
+                <a:spcPts val="0"/>
+              </a:spcAft>
+            </a:pPr>
+            <a:r>
+              <a:rPr sz="1400" b="1" i="0">
+                <a:solidFill>
+                  <a:srgbClr val="000000"/>
+                </a:solidFill>
+                <a:latin typeface="Calibri"/>
+              </a:rPr>
+              <a:t>Worked example — the first two clauses of four_sat_000. Positive literal → (1 − x) → (I + Z)/2. Negated literal → x → (I − Z)/2.</a:t>
+            </a:r>
+            <a:endParaRPr sz="1400" b="1" i="0">
+              <a:solidFill>
+                <a:srgbClr val="000000"/>
+              </a:solidFill>
+              <a:latin typeface="Calibri"/>
+            </a:endParaRPr>
+          </a:p>
+        </p:txBody>
+      </p:sp>
+      <p:pic>
+        <p:nvPicPr>
+          <p:cNvPr id="8" name="Picture 7" descr="worked.png"/>
           <p:cNvPicPr>
             <a:picLocks noChangeAspect="1"/>
           </p:cNvPicPr>
@@ -5250,73 +5423,6 @@
         </p:blipFill>
         <p:spPr>
           <a:xfrm>
-            <a:off x="365760" y="1152144"/>
-            <a:ext cx="7486700" cy="2497633"/>
-          </a:xfrm>
-          <a:prstGeom prst="rect">
-            <a:avLst/>
-          </a:prstGeom>
-        </p:spPr>
-      </p:pic>
-      <p:sp>
-        <p:nvSpPr>
-          <p:cNvPr id="7" name="TextBox 6"/>
-          <p:cNvSpPr txBox="1"/>
-          <p:nvPr/>
-        </p:nvSpPr>
-        <p:spPr>
-          <a:xfrm>
-            <a:off x="457200" y="3722928"/>
-            <a:ext cx="11247120" cy="292608"/>
-          </a:xfrm>
-          <a:prstGeom prst="rect">
-            <a:avLst/>
-          </a:prstGeom>
-          <a:noFill/>
-        </p:spPr>
-        <p:txBody>
-          <a:bodyPr wrap="square"/>
-          <a:lstStyle/>
-          <a:p>
-            <a:pPr>
-              <a:lnSpc>
-                <a:spcPct val="112000"/>
-              </a:lnSpc>
-              <a:spcBef>
-                <a:spcPts val="0"/>
-              </a:spcBef>
-              <a:spcAft>
-                <a:spcPts val="0"/>
-              </a:spcAft>
-            </a:pPr>
-            <a:r>
-              <a:rPr sz="1400" b="1" i="0">
-                <a:solidFill>
-                  <a:srgbClr val="000000"/>
-                </a:solidFill>
-                <a:latin typeface="Calibri"/>
-              </a:rPr>
-              <a:t>Worked example — the first two clauses of four_sat_000. Positive literal → (1 − x) → (I + Z)/2. Negated literal → x → (I − Z)/2.</a:t>
-            </a:r>
-          </a:p>
-        </p:txBody>
-      </p:sp>
-      <p:pic>
-        <p:nvPicPr>
-          <p:cNvPr id="8" name="Picture 7" descr="worked.png"/>
-          <p:cNvPicPr>
-            <a:picLocks noChangeAspect="1"/>
-          </p:cNvPicPr>
-          <p:nvPr/>
-        </p:nvPicPr>
-        <p:blipFill>
-          <a:blip r:embed="rId3"/>
-          <a:stretch>
-            <a:fillRect/>
-          </a:stretch>
-        </p:blipFill>
-        <p:spPr>
-          <a:xfrm>
             <a:off x="365760" y="3997248"/>
             <a:ext cx="11155680" cy="1541454"/>
           </a:xfrm>
@@ -5365,6 +5471,12 @@
               </a:rPr>
               <a:t>Unique ground state of four_sat_000: 1010001, energy 0, gap 1. Full Pauli expansion: 35 Z-strings plus an identity shift — stored in the NPZ, not shown.</a:t>
             </a:r>
+            <a:endParaRPr sz="1400" b="0" i="0">
+              <a:solidFill>
+                <a:srgbClr val="000000"/>
+              </a:solidFill>
+              <a:latin typeface="Calibri"/>
+            </a:endParaRPr>
           </a:p>
         </p:txBody>
       </p:sp>
@@ -5692,6 +5804,10 @@
       </a:style>
     </a:lnDef>
   </a:objectDefaults>
-  <a:extraClrSchemeLst/>
+  <a:extLst>
+    <a:ext uri="{05A4C25C-085E-4340-85A3-A5531E510DB2}">
+      <thm15:themeFamily xmlns:thm15="http://schemas.microsoft.com/office/thememl/2012/main" name="Office Theme" id="{62F939B6-93AF-4DB8-9C6B-D6C7DFDC589F}" vid="{4A3C46E8-61CC-4603-A589-7422A47A8E4A}"/>
+    </a:ext>
+  </a:extLst>
 </a:theme>
 </file>
</xml_diff>